<commit_message>
docs: document signal-excluded beta (--trim) (#6)
Describe the --trim enhancement in the common-mode-cancellation write-up and the
overview deck.

- common-mode-cancellation.md: new "signal-excluded beta" subsection in the approach
  (estimate beta on noise-only cells -- drop the top 5% of STFT cells by power --
  so a strong signal cannot capture beta; beta stays one scalar, C stays time-domain;
  --trim 0 is the exact previous estimate; beta(f) measured flat so no sectioned beta).
  Add the trim result and the PSKreporter validation to the evidence, a --trim option
  bullet, and update the caveats (trim mitigates the net-negative bands; beta drifts
  over the hour, so per-window estimation stays).
- fcfb-overview.pptx/.pdf: new slide "Signal-excluded beta -- recovering weak signals"
  (problem / fix / validation), regenerated PDF.

Co-Authored-By: Claude Opus 4.8 <noreply@anthropic.com>
</commit_message>
<xml_diff>
--- a/docs/fcfb-overview.pptx
+++ b/docs/fcfb-overview.pptx
@@ -15,6 +15,7 @@
     <p:sldId id="263" r:id="rId14"/>
     <p:sldId id="264" r:id="rId15"/>
     <p:sldId id="265" r:id="rId16"/>
+    <p:sldId id="266" r:id="rId17"/>
   </p:sldIdLst>
   <p:sldSz cx="12191695" cy="6858000" type="screen4x3"/>
   <p:notesSz cx="6858000" cy="9144000"/>
@@ -3625,6 +3626,161 @@
                 <a:latin typeface="Calibri"/>
               </a:rPr>
               <a:t>10</a:t>
+            </a:r>
+          </a:p>
+        </p:txBody>
+      </p:sp>
+    </p:spTree>
+  </p:cSld>
+  <p:clrMapOvr>
+    <a:masterClrMapping/>
+  </p:clrMapOvr>
+</p:sld>
+</file>
+
+<file path=ppt/slides/slide11.xml><?xml version="1.0" encoding="utf-8"?>
+<p:sld xmlns:a="http://schemas.openxmlformats.org/drawingml/2006/main" xmlns:p="http://schemas.openxmlformats.org/presentationml/2006/main" xmlns:r="http://schemas.openxmlformats.org/officeDocument/2006/relationships">
+  <p:cSld>
+    <p:bg>
+      <p:bgPr>
+        <a:solidFill>
+          <a:srgbClr val="FFFFFF"/>
+        </a:solidFill>
+        <a:effectLst/>
+      </p:bgPr>
+    </p:bg>
+    <p:spTree>
+      <p:nvGrpSpPr>
+        <p:cNvPr id="1" name=""/>
+        <p:cNvGrpSpPr/>
+        <p:nvPr/>
+      </p:nvGrpSpPr>
+      <p:grpSpPr/>
+      <p:sp>
+        <p:nvSpPr>
+          <p:cNvPr id="2" name="TextBox 1"/>
+          <p:cNvSpPr txBox="1"/>
+          <p:nvPr/>
+        </p:nvSpPr>
+        <p:spPr>
+          <a:xfrm>
+            <a:off x="566928" y="365760"/>
+            <a:ext cx="11064240" cy="731520"/>
+          </a:xfrm>
+          <a:prstGeom prst="rect">
+            <a:avLst/>
+          </a:prstGeom>
+          <a:noFill/>
+        </p:spPr>
+        <p:txBody>
+          <a:bodyPr wrap="square" anchor="ctr" lIns="0" rIns="0" tIns="0" bIns="0">
+            <a:spAutoFit/>
+          </a:bodyPr>
+          <a:lstStyle/>
+          <a:p>
+            <a:pPr algn="l"/>
+            <a:r>
+              <a:rPr sz="2800" b="1" i="0">
+                <a:solidFill>
+                  <a:srgbClr val="0F172A"/>
+                </a:solidFill>
+                <a:latin typeface="Calibri"/>
+              </a:rPr>
+              <a:t>Signal-excluded β — recovering weak signals</a:t>
+            </a:r>
+          </a:p>
+        </p:txBody>
+      </p:sp>
+      <p:pic>
+        <p:nvPicPr>
+          <p:cNvPr id="3" name="Picture 2" descr="signal-excluded beta: problem, fix, validation"/>
+          <p:cNvPicPr>
+            <a:picLocks noChangeAspect="1"/>
+          </p:cNvPicPr>
+          <p:nvPr/>
+        </p:nvPicPr>
+        <p:blipFill>
+          <a:blip r:embed="rId2"/>
+          <a:stretch>
+            <a:fillRect/>
+          </a:stretch>
+        </p:blipFill>
+        <p:spPr>
+          <a:xfrm>
+            <a:off x="548640" y="1436039"/>
+            <a:ext cx="11155680" cy="4525417"/>
+          </a:xfrm>
+          <a:prstGeom prst="rect">
+            <a:avLst/>
+          </a:prstGeom>
+        </p:spPr>
+      </p:pic>
+      <p:sp>
+        <p:nvSpPr>
+          <p:cNvPr id="4" name="TextBox 3"/>
+          <p:cNvSpPr txBox="1"/>
+          <p:nvPr/>
+        </p:nvSpPr>
+        <p:spPr>
+          <a:xfrm>
+            <a:off x="566928" y="6437376"/>
+            <a:ext cx="8686800" cy="274320"/>
+          </a:xfrm>
+          <a:prstGeom prst="rect">
+            <a:avLst/>
+          </a:prstGeom>
+          <a:noFill/>
+        </p:spPr>
+        <p:txBody>
+          <a:bodyPr wrap="square" anchor="ctr" lIns="0" rIns="0" tIns="0" bIns="0">
+            <a:spAutoFit/>
+          </a:bodyPr>
+          <a:lstStyle/>
+          <a:p>
+            <a:pPr algn="l"/>
+            <a:r>
+              <a:rPr sz="900" b="0" i="0">
+                <a:solidFill>
+                  <a:srgbClr val="64748B"/>
+                </a:solidFill>
+                <a:latin typeface="Calibri"/>
+              </a:rPr>
+              <a:t>fcfb — split fast-convolution filter bank for the TRX-duo  ·  Franco Venturi, K4VZ</a:t>
+            </a:r>
+          </a:p>
+        </p:txBody>
+      </p:sp>
+      <p:sp>
+        <p:nvSpPr>
+          <p:cNvPr id="5" name="TextBox 4"/>
+          <p:cNvSpPr txBox="1"/>
+          <p:nvPr/>
+        </p:nvSpPr>
+        <p:spPr>
+          <a:xfrm>
+            <a:off x="10972800" y="6437376"/>
+            <a:ext cx="667512" cy="274320"/>
+          </a:xfrm>
+          <a:prstGeom prst="rect">
+            <a:avLst/>
+          </a:prstGeom>
+          <a:noFill/>
+        </p:spPr>
+        <p:txBody>
+          <a:bodyPr wrap="square" anchor="ctr" lIns="0" rIns="0" tIns="0" bIns="0">
+            <a:spAutoFit/>
+          </a:bodyPr>
+          <a:lstStyle/>
+          <a:p>
+            <a:pPr algn="r"/>
+            <a:r>
+              <a:rPr sz="900" b="0" i="0">
+                <a:solidFill>
+                  <a:srgbClr val="64748B"/>
+                </a:solidFill>
+                <a:latin typeface="Calibri"/>
+              </a:rPr>
+              <a:t>11</a:t>
             </a:r>
           </a:p>
         </p:txBody>

</xml_diff>